<commit_message>
Update presentation: team RSST, LLM evaluation results, gpt-4o-mini wording, PDF export
</commit_message>
<xml_diff>
--- a/docs/ShieldWall_presentation.pptx
+++ b/docs/ShieldWall_presentation.pptx
@@ -1588,7 +1588,7 @@
         <p:spPr>
           <a:xfrm>
             <a:off x="640080" y="731520"/>
-            <a:ext cx="7315200" cy="320040"/>
+            <a:ext cx="4754880" cy="320040"/>
           </a:xfrm>
           <a:prstGeom prst="rect">
             <a:avLst/>
@@ -1624,7 +1624,7 @@
         <p:spPr>
           <a:xfrm>
             <a:off x="640080" y="1554480"/>
-            <a:ext cx="7863840" cy="1097280"/>
+            <a:ext cx="4754880" cy="1097280"/>
           </a:xfrm>
           <a:prstGeom prst="rect">
             <a:avLst/>
@@ -1681,7 +1681,7 @@
                   <a:schemeClr val="bg2"/>
                 </a:solidFill>
               </a:rPr>
-              <a:t>An eBPF/XDP engine that detects and stops DDoS attacks on small servers in seconds, and explains itself in plain English with an LLM.</a:t>
+              <a:t>An eBPF/XDP engine that stops DDoS attacks on small servers in seconds and explains itself in plain English with gpt-4o-mini.</a:t>
             </a:r>
             <a:endParaRPr lang="en-US" sz="2000" dirty="0"/>
           </a:p>
@@ -1810,6 +1810,240 @@
               <a:t>Detect, Mitigate, Explain</a:t>
             </a:r>
             <a:endParaRPr lang="en-US" sz="1400" dirty="0"/>
+          </a:p>
+        </p:txBody>
+      </p:sp>
+      <p:sp>
+        <p:nvSpPr>
+          <p:cNvPr id="9" name="Team panel"/>
+          <p:cNvSpPr/>
+          <p:nvPr/>
+        </p:nvSpPr>
+        <p:spPr>
+          <a:xfrm>
+            <a:off x="5394960" y="731520"/>
+            <a:ext cx="3108960" cy="1696720"/>
+          </a:xfrm>
+          <a:prstGeom prst="roundRect">
+            <a:avLst>
+              <a:gd name="adj" fmla="val 6000"/>
+            </a:avLst>
+          </a:prstGeom>
+          <a:solidFill>
+            <a:schemeClr val="tx2"/>
+          </a:solidFill>
+          <a:ln w="12700">
+            <a:solidFill>
+              <a:schemeClr val="tx2"/>
+            </a:solidFill>
+            <a:prstDash val="solid"/>
+          </a:ln>
+        </p:spPr>
+      </p:sp>
+      <p:sp>
+        <p:nvSpPr>
+          <p:cNvPr id="10" name="Team label"/>
+          <p:cNvSpPr txBox="1"/>
+          <p:nvPr/>
+        </p:nvSpPr>
+        <p:spPr>
+          <a:xfrm>
+            <a:off x="5577840" y="914400"/>
+            <a:ext cx="2743200" cy="228600"/>
+          </a:xfrm>
+          <a:prstGeom prst="rect">
+            <a:avLst/>
+          </a:prstGeom>
+          <a:noFill/>
+          <a:ln/>
+        </p:spPr>
+        <p:txBody>
+          <a:bodyPr wrap="none" lIns="0" tIns="0" rIns="0" bIns="0" rtlCol="0" anchor="t"/>
+          <a:lstStyle/>
+          <a:p>
+            <a:pPr indent="0" marL="0">
+              <a:buNone/>
+            </a:pPr>
+            <a:r>
+              <a:rPr lang="en-US" sz="1200" b="1" spc="300" kern="0" dirty="0">
+                <a:solidFill>
+                  <a:schemeClr val="accent1"/>
+                </a:solidFill>
+              </a:rPr>
+              <a:t>TEAM RSST</a:t>
+            </a:r>
+          </a:p>
+        </p:txBody>
+      </p:sp>
+      <p:sp>
+        <p:nvSpPr>
+          <p:cNvPr id="11" name="Team names"/>
+          <p:cNvSpPr txBox="1"/>
+          <p:nvPr/>
+        </p:nvSpPr>
+        <p:spPr>
+          <a:xfrm>
+            <a:off x="5577840" y="1188720"/>
+            <a:ext cx="1645920" cy="1056640"/>
+          </a:xfrm>
+          <a:prstGeom prst="rect">
+            <a:avLst/>
+          </a:prstGeom>
+          <a:noFill/>
+          <a:ln/>
+        </p:spPr>
+        <p:txBody>
+          <a:bodyPr wrap="none" lIns="0" tIns="0" rIns="0" bIns="0" rtlCol="0" anchor="t"/>
+          <a:lstStyle/>
+          <a:p>
+            <a:pPr indent="0" marL="0" algn="l">
+              <a:spcBef>
+                <a:spcPts val="400"/>
+              </a:spcBef>
+              <a:buNone/>
+            </a:pPr>
+            <a:r>
+              <a:rPr lang="en-US" sz="1400" dirty="0">
+                <a:solidFill>
+                  <a:schemeClr val="bg1"/>
+                </a:solidFill>
+              </a:rPr>
+              <a:t>Rohit Jaysheel Diggi</a:t>
+            </a:r>
+          </a:p>
+          <a:p>
+            <a:pPr indent="0" marL="0" algn="l">
+              <a:spcBef>
+                <a:spcPts val="400"/>
+              </a:spcBef>
+              <a:buNone/>
+            </a:pPr>
+            <a:r>
+              <a:rPr lang="en-US" sz="1400" dirty="0">
+                <a:solidFill>
+                  <a:schemeClr val="bg1"/>
+                </a:solidFill>
+              </a:rPr>
+              <a:t>Saran Chekka</a:t>
+            </a:r>
+          </a:p>
+          <a:p>
+            <a:pPr indent="0" marL="0" algn="l">
+              <a:spcBef>
+                <a:spcPts val="400"/>
+              </a:spcBef>
+              <a:buNone/>
+            </a:pPr>
+            <a:r>
+              <a:rPr lang="en-US" sz="1400" dirty="0">
+                <a:solidFill>
+                  <a:schemeClr val="bg1"/>
+                </a:solidFill>
+              </a:rPr>
+              <a:t>Sushrith Kandagatla</a:t>
+            </a:r>
+          </a:p>
+          <a:p>
+            <a:pPr indent="0" marL="0" algn="l">
+              <a:spcBef>
+                <a:spcPts val="400"/>
+              </a:spcBef>
+              <a:buNone/>
+            </a:pPr>
+            <a:r>
+              <a:rPr lang="en-US" sz="1400" dirty="0">
+                <a:solidFill>
+                  <a:schemeClr val="bg1"/>
+                </a:solidFill>
+              </a:rPr>
+              <a:t>Tamish Sridatta Billa</a:t>
+            </a:r>
+          </a:p>
+        </p:txBody>
+      </p:sp>
+      <p:sp>
+        <p:nvSpPr>
+          <p:cNvPr id="12" name="Team USNs"/>
+          <p:cNvSpPr txBox="1"/>
+          <p:nvPr/>
+        </p:nvSpPr>
+        <p:spPr>
+          <a:xfrm>
+            <a:off x="6995160" y="1188720"/>
+            <a:ext cx="1325880" cy="1056640"/>
+          </a:xfrm>
+          <a:prstGeom prst="rect">
+            <a:avLst/>
+          </a:prstGeom>
+          <a:noFill/>
+          <a:ln/>
+        </p:spPr>
+        <p:txBody>
+          <a:bodyPr wrap="none" lIns="0" tIns="0" rIns="0" bIns="0" rtlCol="0" anchor="t"/>
+          <a:lstStyle/>
+          <a:p>
+            <a:pPr indent="0" marL="0" algn="r">
+              <a:spcBef>
+                <a:spcPts val="400"/>
+              </a:spcBef>
+              <a:buNone/>
+            </a:pPr>
+            <a:r>
+              <a:rPr lang="en-US" sz="1400" dirty="0">
+                <a:solidFill>
+                  <a:srgbClr val="9FB0C8"/>
+                </a:solidFill>
+              </a:rPr>
+              <a:t>1RVU23CSE384</a:t>
+            </a:r>
+          </a:p>
+          <a:p>
+            <a:pPr indent="0" marL="0" algn="r">
+              <a:spcBef>
+                <a:spcPts val="400"/>
+              </a:spcBef>
+              <a:buNone/>
+            </a:pPr>
+            <a:r>
+              <a:rPr lang="en-US" sz="1400" dirty="0">
+                <a:solidFill>
+                  <a:srgbClr val="9FB0C8"/>
+                </a:solidFill>
+              </a:rPr>
+              <a:t>1RVU23CSE411</a:t>
+            </a:r>
+          </a:p>
+          <a:p>
+            <a:pPr indent="0" marL="0" algn="r">
+              <a:spcBef>
+                <a:spcPts val="400"/>
+              </a:spcBef>
+              <a:buNone/>
+            </a:pPr>
+            <a:r>
+              <a:rPr lang="en-US" sz="1400" dirty="0">
+                <a:solidFill>
+                  <a:srgbClr val="9FB0C8"/>
+                </a:solidFill>
+              </a:rPr>
+              <a:t>1RVU23CSE489</a:t>
+            </a:r>
+          </a:p>
+          <a:p>
+            <a:pPr indent="0" marL="0" algn="r">
+              <a:spcBef>
+                <a:spcPts val="400"/>
+              </a:spcBef>
+              <a:buNone/>
+            </a:pPr>
+            <a:r>
+              <a:rPr lang="en-US" sz="1400" dirty="0">
+                <a:solidFill>
+                  <a:srgbClr val="9FB0C8"/>
+                </a:solidFill>
+              </a:rPr>
+              <a:t>1RVU23CSE498</a:t>
+            </a:r>
           </a:p>
         </p:txBody>
       </p:sp>
@@ -2793,7 +3027,7 @@
                   <a:schemeClr val="tx1"/>
                 </a:solidFill>
               </a:rPr>
-              <a:t> An LLM writes plain-English summaries but never makes blocking decisions.</a:t>
+              <a:t> gpt-4o-mini writes plain-English summaries but never makes blocking decisions.</a:t>
             </a:r>
             <a:endParaRPr lang="en-US" sz="1400" dirty="0"/>
           </a:p>
@@ -2978,8 +3212,8 @@
         </p:nvSpPr>
         <p:spPr>
           <a:xfrm>
-            <a:off x="6446520" y="2057400"/>
-            <a:ext cx="2011680" cy="2286000"/>
+            <a:off x="6446520" y="2011680"/>
+            <a:ext cx="2011680" cy="2331720"/>
           </a:xfrm>
           <a:prstGeom prst="rect">
             <a:avLst/>
@@ -2995,14 +3229,46 @@
               <a:buNone/>
             </a:pPr>
             <a:r>
-              <a:rPr lang="en-US" sz="1400" dirty="0">
+              <a:rPr lang="en-US" sz="1300" dirty="0">
                 <a:solidFill>
                   <a:schemeClr val="bg1"/>
                 </a:solidFill>
               </a:rPr>
-              <a:t>A flood bigger than the server's internet link can't be fixed locally. That needs upstream help (RTBH or BGP FlowSpec), planned as a stretch goal.</a:t>
-            </a:r>
-            <a:endParaRPr lang="en-US" sz="1400" dirty="0"/>
+              <a:t>Floods bigger than the internet link need upstream help, so ShieldWall asks the provider to filter them (BGP FlowSpec).</a:t>
+            </a:r>
+          </a:p>
+          <a:p>
+            <a:pPr indent="0" marL="0">
+              <a:spcBef>
+                <a:spcPts val="1400"/>
+              </a:spcBef>
+              <a:buNone/>
+            </a:pPr>
+            <a:r>
+              <a:rPr lang="en-US" sz="1800" b="1" dirty="0">
+                <a:solidFill>
+                  <a:schemeClr val="accent2"/>
+                </a:solidFill>
+              </a:rPr>
+              <a:t>No training needed</a:t>
+            </a:r>
+          </a:p>
+          <a:p>
+            <a:pPr indent="0" marL="0">
+              <a:spcBef>
+                <a:spcPts val="600"/>
+              </a:spcBef>
+              <a:buNone/>
+            </a:pPr>
+            <a:r>
+              <a:rPr lang="en-US" sz="1300" dirty="0">
+                <a:solidFill>
+                  <a:schemeClr val="bg1"/>
+                </a:solidFill>
+              </a:rPr>
+              <a:t>It learns each server's normal traffic live. No dataset, no retraining.</a:t>
+            </a:r>
+            <a:endParaRPr lang="en-US" sz="1300" dirty="0"/>
           </a:p>
         </p:txBody>
       </p:sp>
@@ -3270,7 +3536,7 @@
                   <a:schemeClr val="tx1"/>
                 </a:solidFill>
               </a:rPr>
-              <a:t>botnet replay</a:t>
+              <a:t>botnet / reflectors</a:t>
             </a:r>
             <a:endParaRPr lang="en-US" sz="1200" dirty="0"/>
           </a:p>
@@ -3347,7 +3613,7 @@
                   <a:schemeClr val="tx1"/>
                 </a:solidFill>
               </a:rPr>
-              <a:t>k6 / game clients</a:t>
+              <a:t>game clients</a:t>
             </a:r>
             <a:endParaRPr lang="en-US" sz="1200" dirty="0"/>
           </a:p>
@@ -3872,7 +4138,7 @@
                   <a:schemeClr val="bg1"/>
                 </a:solidFill>
               </a:rPr>
-              <a:t>LLM assistant + SQL log</a:t>
+              <a:t>gpt-4o-mini + SQL log</a:t>
             </a:r>
             <a:endParaRPr lang="en-US" sz="1200" dirty="0"/>
           </a:p>
@@ -4398,6 +4664,24 @@
             </a:r>
             <a:endParaRPr lang="en-US" sz="1200" dirty="0"/>
           </a:p>
+          <a:p>
+            <a:pPr marL="342900" indent="-342900">
+              <a:spcAft>
+                <a:spcPts val="400"/>
+              </a:spcAft>
+              <a:buSzPct val="100000"/>
+              <a:buChar char="•"/>
+            </a:pPr>
+            <a:r>
+              <a:rPr lang="en-US" sz="1200" dirty="0">
+                <a:solidFill>
+                  <a:schemeClr val="accent6"/>
+                </a:solidFill>
+              </a:rPr>
+              <a:t>No training: learns normal traffic live</a:t>
+            </a:r>
+            <a:endParaRPr lang="en-US" sz="1200" dirty="0"/>
+          </a:p>
         </p:txBody>
       </p:sp>
       <p:sp>
@@ -4740,7 +5024,7 @@
                   <a:schemeClr val="accent6"/>
                 </a:solidFill>
               </a:rPr>
-              <a:t>LLM writes the incident summary</a:t>
+              <a:t>gpt-4o-mini writes the incident summary</a:t>
             </a:r>
             <a:endParaRPr lang="en-US" sz="1200" dirty="0"/>
           </a:p>
@@ -4776,7 +5060,7 @@
                   <a:schemeClr val="accent6"/>
                 </a:solidFill>
               </a:rPr>
-              <a:t>Claude, Ollama or built-in wording</a:t>
+              <a:t>Checked: 0 made-up numbers</a:t>
             </a:r>
             <a:endParaRPr lang="en-US" sz="1200" dirty="0"/>
           </a:p>
@@ -4868,7 +5152,7 @@
                   <a:schemeClr val="bg1"/>
                 </a:solidFill>
               </a:rPr>
-              <a:t>C + eBPF/XDP (kernel), Python + bpftool (control), SQLite, Claude API / Ollama, scapy kernel test, live web dashboard, pytest + GitHub Actions</a:t>
+              <a:t>C + eBPF/XDP (kernel), Python + bpftool (control), SQLite, OpenAI gpt-4o-mini, scapy kernel test, live web dashboard, pytest + GitHub Actions</a:t>
             </a:r>
             <a:endParaRPr lang="en-US" sz="1200" dirty="0"/>
           </a:p>
@@ -5015,8 +5299,8 @@
         </p:nvSpPr>
         <p:spPr>
           <a:xfrm>
-            <a:off x="640080" y="1920240"/>
-            <a:ext cx="2560320" cy="2011680"/>
+            <a:off x="640080" y="1874520"/>
+            <a:ext cx="2560320" cy="2103120"/>
           </a:xfrm>
           <a:prstGeom prst="rect">
             <a:avLst/>
@@ -5030,78 +5314,185 @@
           <a:p>
             <a:pPr marL="342900" indent="-342900">
               <a:spcAft>
-                <a:spcPts val="600"/>
+                <a:spcPts val="200"/>
               </a:spcAft>
               <a:buSzPct val="100000"/>
               <a:buFont typeface="+mj-lt"/>
               <a:buAutoNum type="arabicPeriod" startAt="1"/>
             </a:pPr>
             <a:r>
-              <a:rPr lang="en-US" sz="1400" dirty="0">
+              <a:rPr lang="en-US" sz="1300" dirty="0">
                 <a:solidFill>
                   <a:schemeClr val="tx1"/>
                 </a:solidFill>
               </a:rPr>
               <a:t>Clean attack</a:t>
             </a:r>
-            <a:endParaRPr lang="en-US" sz="1400" dirty="0"/>
+            <a:endParaRPr lang="en-US" sz="1300" dirty="0"/>
           </a:p>
           <a:p>
             <a:pPr marL="342900" indent="-342900">
               <a:spcAft>
-                <a:spcPts val="600"/>
+                <a:spcPts val="200"/>
               </a:spcAft>
               <a:buSzPct val="100000"/>
               <a:buFont typeface="+mj-lt"/>
               <a:buAutoNum type="arabicPeriod" startAt="1"/>
             </a:pPr>
             <a:r>
-              <a:rPr lang="en-US" sz="1400" dirty="0">
+              <a:rPr lang="en-US" sz="1300" dirty="0">
                 <a:solidFill>
                   <a:schemeClr val="tx1"/>
                 </a:solidFill>
               </a:rPr>
               <a:t>Attack mixed with real traffic</a:t>
             </a:r>
-            <a:endParaRPr lang="en-US" sz="1400" dirty="0"/>
+            <a:endParaRPr lang="en-US" sz="1300" dirty="0"/>
           </a:p>
           <a:p>
             <a:pPr marL="342900" indent="-342900">
               <a:spcAft>
-                <a:spcPts val="600"/>
+                <a:spcPts val="200"/>
               </a:spcAft>
               <a:buSzPct val="100000"/>
               <a:buFont typeface="+mj-lt"/>
               <a:buAutoNum type="arabicPeriod" startAt="1"/>
             </a:pPr>
             <a:r>
-              <a:rPr lang="en-US" sz="1400" dirty="0">
+              <a:rPr lang="en-US" sz="1300" dirty="0">
                 <a:solidFill>
                   <a:schemeClr val="tx1"/>
                 </a:solidFill>
               </a:rPr>
               <a:t>Legitimate spike, no attack</a:t>
             </a:r>
-            <a:endParaRPr lang="en-US" sz="1400" dirty="0"/>
+            <a:endParaRPr lang="en-US" sz="1300" dirty="0"/>
           </a:p>
           <a:p>
             <a:pPr marL="342900" indent="-342900">
               <a:spcAft>
-                <a:spcPts val="600"/>
+                <a:spcPts val="200"/>
               </a:spcAft>
               <a:buSzPct val="100000"/>
               <a:buFont typeface="+mj-lt"/>
               <a:buAutoNum type="arabicPeriod" startAt="1"/>
             </a:pPr>
             <a:r>
-              <a:rPr lang="en-US" sz="1400" dirty="0">
+              <a:rPr lang="en-US" sz="1300" dirty="0">
                 <a:solidFill>
                   <a:schemeClr val="tx1"/>
                 </a:solidFill>
               </a:rPr>
               <a:t>Attack bigger than the link</a:t>
             </a:r>
-            <a:endParaRPr lang="en-US" sz="1400" dirty="0"/>
+            <a:endParaRPr lang="en-US" sz="1300" dirty="0"/>
+          </a:p>
+          <a:p>
+            <a:pPr indent="0" marL="0">
+              <a:spcBef>
+                <a:spcPts val="800"/>
+              </a:spcBef>
+              <a:spcAft>
+                <a:spcPts val="200"/>
+              </a:spcAft>
+              <a:buNone/>
+            </a:pPr>
+            <a:r>
+              <a:rPr lang="en-US" sz="1600" b="1" dirty="0">
+                <a:solidFill>
+                  <a:schemeClr val="accent1"/>
+                </a:solidFill>
+              </a:rPr>
+              <a:t>LLM check (gpt-4o-mini)</a:t>
+            </a:r>
+          </a:p>
+          <a:p>
+            <a:pPr indent="0" marL="0">
+              <a:spcAft>
+                <a:spcPts val="100"/>
+              </a:spcAft>
+              <a:buNone/>
+            </a:pPr>
+            <a:r>
+              <a:rPr lang="en-US" sz="1300" b="1" dirty="0">
+                <a:solidFill>
+                  <a:srgbClr val="1F8A5B"/>
+                </a:solidFill>
+              </a:rPr>
+              <a:t>100%</a:t>
+            </a:r>
+            <a:r>
+              <a:rPr lang="en-US" sz="1300" dirty="0">
+                <a:solidFill>
+                  <a:schemeClr val="tx1"/>
+                </a:solidFill>
+              </a:rPr>
+              <a:t> numbers grounded (49/49)</a:t>
+            </a:r>
+          </a:p>
+          <a:p>
+            <a:pPr indent="0" marL="0">
+              <a:spcAft>
+                <a:spcPts val="100"/>
+              </a:spcAft>
+              <a:buNone/>
+            </a:pPr>
+            <a:r>
+              <a:rPr lang="en-US" sz="1300" b="1" dirty="0">
+                <a:solidFill>
+                  <a:srgbClr val="1F8A5B"/>
+                </a:solidFill>
+              </a:rPr>
+              <a:t>100%</a:t>
+            </a:r>
+            <a:r>
+              <a:rPr lang="en-US" sz="1300" dirty="0">
+                <a:solidFill>
+                  <a:schemeClr val="tx1"/>
+                </a:solidFill>
+              </a:rPr>
+              <a:t> named the right attack</a:t>
+            </a:r>
+          </a:p>
+          <a:p>
+            <a:pPr indent="0" marL="0">
+              <a:spcAft>
+                <a:spcPts val="100"/>
+              </a:spcAft>
+              <a:buNone/>
+            </a:pPr>
+            <a:r>
+              <a:rPr lang="en-US" sz="1300" b="1" dirty="0">
+                <a:solidFill>
+                  <a:srgbClr val="1F8A5B"/>
+                </a:solidFill>
+              </a:rPr>
+              <a:t>1.6 s</a:t>
+            </a:r>
+            <a:r>
+              <a:rPr lang="en-US" sz="1300" dirty="0">
+                <a:solidFill>
+                  <a:schemeClr val="tx1"/>
+                </a:solidFill>
+              </a:rPr>
+              <a:t> reply, </a:t>
+            </a:r>
+            <a:r>
+              <a:rPr lang="en-US" sz="1300" b="1" dirty="0">
+                <a:solidFill>
+                  <a:srgbClr val="1F8A5B"/>
+                </a:solidFill>
+              </a:rPr>
+              <a:t>$0.00008</a:t>
+            </a:r>
+            <a:r>
+              <a:rPr lang="en-US" sz="1300" dirty="0">
+                <a:solidFill>
+                  <a:schemeClr val="tx1"/>
+                </a:solidFill>
+              </a:rPr>
+              <a:t> each</a:t>
+            </a:r>
           </a:p>
         </p:txBody>
       </p:sp>
@@ -6609,7 +7000,7 @@
                   <a:schemeClr val="bg1"/>
                 </a:solidFill>
               </a:rPr>
-              <a:t>Kernel eBPF/XDP, streaming sketches and CUSUM detection.</a:t>
+              <a:t>Kernel eBPF/XDP, streaming sketches, CUSUM detection and a grounded gpt-4o-mini explainer.</a:t>
             </a:r>
             <a:endParaRPr lang="en-US" sz="1200" dirty="0"/>
           </a:p>

</xml_diff>

<commit_message>
Real captures through the real kernel, held-out test, second review fixes
- tests/xdp_replay_test.sh: replays a real attack capture through the XDP
  program with the live control loop; DNS and multi-vector captures:
  98.5% and 99.1% of packets dropped by the kernel, 0 player packets
- Held-out test, run once on frozen code: 5 unseen public captures and
  3 unseen CIC-DDoS2019 files (5 of 8 caught; one real miss, TCP SYN-ACK
  reflection), plus the LLM on unseen incidents
- Every reflection port gets a rule once amplification is confirmed
- XDP blocklist checked before the TCP/UDP branch (covers every protocol),
  entries expire in the kernel, optional per-source rate limit
- A heavy hitter talking to the game ports is rate-limited, not blocked
  (possible shared address); sources trusted only after 5 calm seconds
- Live loop refactored into LiveLoop; wording fixed in README, slides and
  the talk script (same-model judge, CIC caveats, throughput, held-out)
</commit_message>
<xml_diff>
--- a/docs/ShieldWall_presentation.pptx
+++ b/docs/ShieldWall_presentation.pptx
@@ -3250,7 +3250,7 @@
                   <a:schemeClr val="accent2"/>
                 </a:solidFill>
               </a:rPr>
-              <a:t>No training needed</a:t>
+              <a:t>No training data</a:t>
             </a:r>
           </a:p>
           <a:p>
@@ -3266,7 +3266,7 @@
                   <a:schemeClr val="bg1"/>
                 </a:solidFill>
               </a:rPr>
-              <a:t>It learns each server's normal traffic live. No dataset, no retraining.</a:t>
+              <a:t>It learns each server's normal traffic live and keeps adapting. Nothing to retrain.</a:t>
             </a:r>
             <a:endParaRPr lang="en-US" sz="1300" dirty="0"/>
           </a:p>
@@ -5344,7 +5344,7 @@
                   <a:schemeClr val="tx1"/>
                 </a:solidFill>
               </a:rPr>
-              <a:t>Public captures: 3/3 caught</a:t>
+              <a:t>Replayed attacks: 6/6 caught</a:t>
             </a:r>
             <a:endParaRPr lang="en-US" sz="1300" dirty="0"/>
           </a:p>
@@ -5363,7 +5363,7 @@
                   <a:schemeClr val="tx1"/>
                 </a:solidFill>
               </a:rPr>
-              <a:t>CIC-DDoS2019: 3/3 caught</a:t>
+              <a:t>Real kernel: 98.5-99.1% dropped</a:t>
             </a:r>
             <a:endParaRPr lang="en-US" sz="1300" dirty="0"/>
           </a:p>
@@ -5382,7 +5382,7 @@
                   <a:schemeClr val="tx1"/>
                 </a:solidFill>
               </a:rPr>
-              <a:t>All blocked within 3 s</a:t>
+              <a:t>Held-out: 5/8 caught</a:t>
             </a:r>
             <a:endParaRPr lang="en-US" sz="1300" dirty="0"/>
           </a:p>
@@ -5401,7 +5401,7 @@
                   <a:schemeClr val="tx1"/>
                 </a:solidFill>
               </a:rPr>
-              <a:t>Kernel: 3,000/3,000 dropped</a:t>
+              <a:t>Real miss: SYN-ACK reflection</a:t>
             </a:r>
             <a:endParaRPr lang="en-US" sz="1300" dirty="0"/>
           </a:p>
@@ -5445,7 +5445,7 @@
                   <a:schemeClr val="tx1"/>
                 </a:solidFill>
               </a:rPr>
-              <a:t> numbers grounded (61/61)</a:t>
+              <a:t> numbers grounded (66/66)</a:t>
             </a:r>
           </a:p>
           <a:p>
@@ -5469,7 +5469,7 @@
                   <a:schemeClr val="tx1"/>
                 </a:solidFill>
               </a:rPr>
-              <a:t> claims judged faithful</a:t>
+              <a:t> faithful on unseen incidents</a:t>
             </a:r>
           </a:p>
           <a:p>
@@ -6233,7 +6233,7 @@
                             <a:srgbClr val="1F8A5B"/>
                           </a:solidFill>
                         </a:rPr>
-                        <a:t>95.7-99.3%</a:t>
+                        <a:t>95.7-98.6%</a:t>
                       </a:r>
                       <a:endParaRPr lang="en-US" sz="1300" dirty="0"/>
                     </a:p>
@@ -6693,7 +6693,7 @@
                   <a:schemeClr val="tx1"/>
                 </a:solidFill>
               </a:rPr>
-              <a:t>1,000/1,000 IP fragments and 2,000/2,000 packets from a flooding host dropped, every player packet passed. Table results come from our simulator.</a:t>
+              <a:t>real DNS and multi-vector captures through the XDP program: 98.5% and 99.1% of packets dropped, 0 player packets. Table results come from our simulator.</a:t>
             </a:r>
           </a:p>
         </p:txBody>
@@ -7092,7 +7092,7 @@
                   <a:schemeClr val="bg1"/>
                 </a:solidFill>
               </a:rPr>
-              <a:t>real attack captures and CIC-DDoS2019 replayed and blocked; 3,000/3,000 flood packets dropped on a real Linux kernel.</a:t>
+              <a:t>real captures blocked by the real XDP kernel (98.5-99.1% dropped); 5 of 8 held-out attacks caught, one honest miss.</a:t>
             </a:r>
             <a:endParaRPr lang="en-US" sz="1200" dirty="0"/>
           </a:p>

</xml_diff>